<commit_message>
Date: 29 Jan 2026
</commit_message>
<xml_diff>
--- a/Data Driven Framework.pptx
+++ b/Data Driven Framework.pptx
@@ -10,6 +10,7 @@
     <p:sldId id="258" r:id="rId4"/>
     <p:sldId id="259" r:id="rId5"/>
     <p:sldId id="260" r:id="rId6"/>
+    <p:sldId id="261" r:id="rId7"/>
   </p:sldIdLst>
   <p:sldSz cx="12192000" cy="6858000"/>
   <p:notesSz cx="6858000" cy="9144000"/>
@@ -108,6 +109,11 @@
       </a:defRPr>
     </a:lvl9pPr>
   </p:defaultTextStyle>
+  <p:extLst>
+    <p:ext uri="{EFAFB233-063F-42B5-8137-9DF3F51BA10A}">
+      <p15:sldGuideLst xmlns:p15="http://schemas.microsoft.com/office/powerpoint/2012/main"/>
+    </p:ext>
+  </p:extLst>
 </p:presentation>
 </file>
 
@@ -1845,14 +1851,35 @@
         </dgm:presLayoutVars>
       </dgm:prSet>
       <dgm:spPr/>
+      <dgm:t>
+        <a:bodyPr/>
+        <a:lstStyle/>
+        <a:p>
+          <a:endParaRPr lang="en-IN"/>
+        </a:p>
+      </dgm:t>
     </dgm:pt>
     <dgm:pt modelId="{6EAA46A5-ACAC-4502-974E-632F93CD095C}" type="pres">
       <dgm:prSet presAssocID="{859B2140-4845-4FD9-9851-2D9917CEF781}" presName="sibTrans" presStyleLbl="sibTrans2D1" presStyleIdx="0" presStyleCnt="3"/>
       <dgm:spPr/>
+      <dgm:t>
+        <a:bodyPr/>
+        <a:lstStyle/>
+        <a:p>
+          <a:endParaRPr lang="en-IN"/>
+        </a:p>
+      </dgm:t>
     </dgm:pt>
     <dgm:pt modelId="{F0DC1B2D-69F4-40E7-966D-057A4E85E176}" type="pres">
       <dgm:prSet presAssocID="{859B2140-4845-4FD9-9851-2D9917CEF781}" presName="connectorText" presStyleLbl="sibTrans2D1" presStyleIdx="0" presStyleCnt="3"/>
       <dgm:spPr/>
+      <dgm:t>
+        <a:bodyPr/>
+        <a:lstStyle/>
+        <a:p>
+          <a:endParaRPr lang="en-IN"/>
+        </a:p>
+      </dgm:t>
     </dgm:pt>
     <dgm:pt modelId="{6EA2D6BD-7001-43CA-B291-3FF51EFB498A}" type="pres">
       <dgm:prSet presAssocID="{CE44743D-9D4D-438D-8225-D3A1362521BC}" presName="node" presStyleLbl="node1" presStyleIdx="1" presStyleCnt="4">
@@ -1861,14 +1888,35 @@
         </dgm:presLayoutVars>
       </dgm:prSet>
       <dgm:spPr/>
+      <dgm:t>
+        <a:bodyPr/>
+        <a:lstStyle/>
+        <a:p>
+          <a:endParaRPr lang="en-IN"/>
+        </a:p>
+      </dgm:t>
     </dgm:pt>
     <dgm:pt modelId="{D221B311-B5C1-4AF8-8729-5ADD2C55EA5A}" type="pres">
       <dgm:prSet presAssocID="{F8833BA0-5656-4B30-B80D-BC9351FF85CD}" presName="sibTrans" presStyleLbl="sibTrans2D1" presStyleIdx="1" presStyleCnt="3"/>
       <dgm:spPr/>
+      <dgm:t>
+        <a:bodyPr/>
+        <a:lstStyle/>
+        <a:p>
+          <a:endParaRPr lang="en-IN"/>
+        </a:p>
+      </dgm:t>
     </dgm:pt>
     <dgm:pt modelId="{6BB7B969-2935-4BE4-BEB6-ABBBF9C9A1DE}" type="pres">
       <dgm:prSet presAssocID="{F8833BA0-5656-4B30-B80D-BC9351FF85CD}" presName="connectorText" presStyleLbl="sibTrans2D1" presStyleIdx="1" presStyleCnt="3"/>
       <dgm:spPr/>
+      <dgm:t>
+        <a:bodyPr/>
+        <a:lstStyle/>
+        <a:p>
+          <a:endParaRPr lang="en-IN"/>
+        </a:p>
+      </dgm:t>
     </dgm:pt>
     <dgm:pt modelId="{EC44C685-101C-48A2-9975-E267685AE561}" type="pres">
       <dgm:prSet presAssocID="{8504CB62-E946-4A6B-BD9B-43A4B8947EE1}" presName="node" presStyleLbl="node1" presStyleIdx="2" presStyleCnt="4">
@@ -1877,14 +1925,35 @@
         </dgm:presLayoutVars>
       </dgm:prSet>
       <dgm:spPr/>
+      <dgm:t>
+        <a:bodyPr/>
+        <a:lstStyle/>
+        <a:p>
+          <a:endParaRPr lang="en-IN"/>
+        </a:p>
+      </dgm:t>
     </dgm:pt>
     <dgm:pt modelId="{2C6D5B03-10D3-4DEB-8C11-A3D1DF192EC0}" type="pres">
       <dgm:prSet presAssocID="{5B64D46D-4CA5-4DDC-A7A5-26C47875DC15}" presName="sibTrans" presStyleLbl="sibTrans2D1" presStyleIdx="2" presStyleCnt="3"/>
       <dgm:spPr/>
+      <dgm:t>
+        <a:bodyPr/>
+        <a:lstStyle/>
+        <a:p>
+          <a:endParaRPr lang="en-IN"/>
+        </a:p>
+      </dgm:t>
     </dgm:pt>
     <dgm:pt modelId="{A402635F-D7DE-4E9E-A5D9-75258192A3FF}" type="pres">
       <dgm:prSet presAssocID="{5B64D46D-4CA5-4DDC-A7A5-26C47875DC15}" presName="connectorText" presStyleLbl="sibTrans2D1" presStyleIdx="2" presStyleCnt="3"/>
       <dgm:spPr/>
+      <dgm:t>
+        <a:bodyPr/>
+        <a:lstStyle/>
+        <a:p>
+          <a:endParaRPr lang="en-IN"/>
+        </a:p>
+      </dgm:t>
     </dgm:pt>
     <dgm:pt modelId="{D6F4A607-5F31-4971-95E9-EC3C1EAFCAA1}" type="pres">
       <dgm:prSet presAssocID="{8C0CF771-4F8B-4765-A6B5-E3346251BF5C}" presName="node" presStyleLbl="node1" presStyleIdx="3" presStyleCnt="4">
@@ -1893,14 +1962,21 @@
         </dgm:presLayoutVars>
       </dgm:prSet>
       <dgm:spPr/>
+      <dgm:t>
+        <a:bodyPr/>
+        <a:lstStyle/>
+        <a:p>
+          <a:endParaRPr lang="en-IN"/>
+        </a:p>
+      </dgm:t>
     </dgm:pt>
   </dgm:ptLst>
   <dgm:cxnLst>
     <dgm:cxn modelId="{D1F71552-E960-4993-9AA5-69E9D1C17EC4}" type="presOf" srcId="{859B2140-4845-4FD9-9851-2D9917CEF781}" destId="{6EAA46A5-ACAC-4502-974E-632F93CD095C}" srcOrd="0" destOrd="0" presId="urn:microsoft.com/office/officeart/2005/8/layout/process2"/>
     <dgm:cxn modelId="{3CB4973F-A224-46A8-858B-8294CD13F39C}" type="presOf" srcId="{F8833BA0-5656-4B30-B80D-BC9351FF85CD}" destId="{6BB7B969-2935-4BE4-BEB6-ABBBF9C9A1DE}" srcOrd="1" destOrd="0" presId="urn:microsoft.com/office/officeart/2005/8/layout/process2"/>
     <dgm:cxn modelId="{E5E31D51-7D0C-43C1-93F4-C7BA7EFC652A}" type="presOf" srcId="{F8833BA0-5656-4B30-B80D-BC9351FF85CD}" destId="{D221B311-B5C1-4AF8-8729-5ADD2C55EA5A}" srcOrd="0" destOrd="0" presId="urn:microsoft.com/office/officeart/2005/8/layout/process2"/>
+    <dgm:cxn modelId="{96633661-5C28-4D7D-B03C-93E45F89F525}" srcId="{C3BD96E1-FDA9-4012-8629-58BCD0A3DD86}" destId="{B1BB1FAF-9E98-4D6E-9567-9F3F44412ACE}" srcOrd="0" destOrd="0" parTransId="{FABB7242-FC47-4D8F-BF13-3E83522104C5}" sibTransId="{859B2140-4845-4FD9-9851-2D9917CEF781}"/>
     <dgm:cxn modelId="{D4DC85E0-70D9-4919-99A6-15B2F9AA8ADE}" type="presOf" srcId="{8C0CF771-4F8B-4765-A6B5-E3346251BF5C}" destId="{D6F4A607-5F31-4971-95E9-EC3C1EAFCAA1}" srcOrd="0" destOrd="0" presId="urn:microsoft.com/office/officeart/2005/8/layout/process2"/>
-    <dgm:cxn modelId="{96633661-5C28-4D7D-B03C-93E45F89F525}" srcId="{C3BD96E1-FDA9-4012-8629-58BCD0A3DD86}" destId="{B1BB1FAF-9E98-4D6E-9567-9F3F44412ACE}" srcOrd="0" destOrd="0" parTransId="{FABB7242-FC47-4D8F-BF13-3E83522104C5}" sibTransId="{859B2140-4845-4FD9-9851-2D9917CEF781}"/>
     <dgm:cxn modelId="{765570EE-0EB3-4AFD-A218-DCBDE9CD7F64}" type="presOf" srcId="{5B64D46D-4CA5-4DDC-A7A5-26C47875DC15}" destId="{2C6D5B03-10D3-4DEB-8C11-A3D1DF192EC0}" srcOrd="0" destOrd="0" presId="urn:microsoft.com/office/officeart/2005/8/layout/process2"/>
     <dgm:cxn modelId="{3EA4C2C6-7081-4082-A05F-1484D04ADD3D}" srcId="{C3BD96E1-FDA9-4012-8629-58BCD0A3DD86}" destId="{CE44743D-9D4D-438D-8225-D3A1362521BC}" srcOrd="1" destOrd="0" parTransId="{631ED25F-C9B5-46D1-A9DA-7B59B16C5AE9}" sibTransId="{F8833BA0-5656-4B30-B80D-BC9351FF85CD}"/>
     <dgm:cxn modelId="{3413C798-EB50-4844-B19A-17CABD77BBFA}" type="presOf" srcId="{5B64D46D-4CA5-4DDC-A7A5-26C47875DC15}" destId="{A402635F-D7DE-4E9E-A5D9-75258192A3FF}" srcOrd="1" destOrd="0" presId="urn:microsoft.com/office/officeart/2005/8/layout/process2"/>
@@ -2032,6 +2108,13 @@
         </dgm:presLayoutVars>
       </dgm:prSet>
       <dgm:spPr/>
+      <dgm:t>
+        <a:bodyPr/>
+        <a:lstStyle/>
+        <a:p>
+          <a:endParaRPr lang="en-IN"/>
+        </a:p>
+      </dgm:t>
     </dgm:pt>
     <dgm:pt modelId="{18AB70F2-F9A8-4A92-9B17-67036A642D6A}" type="pres">
       <dgm:prSet presAssocID="{7C426087-5213-420B-BE39-B07699247BE7}" presName="parTxOnlySpace" presStyleCnt="0"/>
@@ -2046,14 +2129,21 @@
         </dgm:presLayoutVars>
       </dgm:prSet>
       <dgm:spPr/>
+      <dgm:t>
+        <a:bodyPr/>
+        <a:lstStyle/>
+        <a:p>
+          <a:endParaRPr lang="en-IN"/>
+        </a:p>
+      </dgm:t>
     </dgm:pt>
   </dgm:ptLst>
   <dgm:cxnLst>
+    <dgm:cxn modelId="{3259AEE0-9D8D-416E-96E1-CC4FE8BDA452}" srcId="{89BFE23F-15CC-4ED4-B796-8B1FE6807D97}" destId="{FD71F628-C8ED-4B46-A9B3-3448AE9451EC}" srcOrd="1" destOrd="0" parTransId="{92C1F11E-D91A-4B44-B535-F1D6BFC18A68}" sibTransId="{2C51F08E-F78D-4A9E-A578-18A9E1456395}"/>
     <dgm:cxn modelId="{034D5DEB-9E2B-4801-9C32-F3246C20DA28}" type="presOf" srcId="{EC0E88AA-2876-4D66-AF84-61E15A589721}" destId="{5E8FED32-6440-4A80-887C-92E96B43FA43}" srcOrd="0" destOrd="0" presId="urn:microsoft.com/office/officeart/2005/8/layout/chevron1"/>
-    <dgm:cxn modelId="{3259AEE0-9D8D-416E-96E1-CC4FE8BDA452}" srcId="{89BFE23F-15CC-4ED4-B796-8B1FE6807D97}" destId="{FD71F628-C8ED-4B46-A9B3-3448AE9451EC}" srcOrd="1" destOrd="0" parTransId="{92C1F11E-D91A-4B44-B535-F1D6BFC18A68}" sibTransId="{2C51F08E-F78D-4A9E-A578-18A9E1456395}"/>
+    <dgm:cxn modelId="{83C950C6-147E-4DEF-AE2C-6ECDEAAD8F7C}" type="presOf" srcId="{FD71F628-C8ED-4B46-A9B3-3448AE9451EC}" destId="{F4DC1C29-125F-43DC-B4CC-037FCD9EF089}" srcOrd="0" destOrd="0" presId="urn:microsoft.com/office/officeart/2005/8/layout/chevron1"/>
+    <dgm:cxn modelId="{03227288-0427-49AF-B52F-EFE5AFD69019}" type="presOf" srcId="{89BFE23F-15CC-4ED4-B796-8B1FE6807D97}" destId="{44F33A45-1B21-4A97-AD63-8DB045734661}" srcOrd="0" destOrd="0" presId="urn:microsoft.com/office/officeart/2005/8/layout/chevron1"/>
     <dgm:cxn modelId="{68474AA4-0860-4A86-9512-388A53CCE4B0}" srcId="{89BFE23F-15CC-4ED4-B796-8B1FE6807D97}" destId="{EC0E88AA-2876-4D66-AF84-61E15A589721}" srcOrd="0" destOrd="0" parTransId="{D975B694-1EEA-45E6-A66B-060BB131ED69}" sibTransId="{7C426087-5213-420B-BE39-B07699247BE7}"/>
-    <dgm:cxn modelId="{03227288-0427-49AF-B52F-EFE5AFD69019}" type="presOf" srcId="{89BFE23F-15CC-4ED4-B796-8B1FE6807D97}" destId="{44F33A45-1B21-4A97-AD63-8DB045734661}" srcOrd="0" destOrd="0" presId="urn:microsoft.com/office/officeart/2005/8/layout/chevron1"/>
-    <dgm:cxn modelId="{83C950C6-147E-4DEF-AE2C-6ECDEAAD8F7C}" type="presOf" srcId="{FD71F628-C8ED-4B46-A9B3-3448AE9451EC}" destId="{F4DC1C29-125F-43DC-B4CC-037FCD9EF089}" srcOrd="0" destOrd="0" presId="urn:microsoft.com/office/officeart/2005/8/layout/chevron1"/>
     <dgm:cxn modelId="{449AAAEF-13CC-4318-A016-AF1BE71D0499}" type="presParOf" srcId="{44F33A45-1B21-4A97-AD63-8DB045734661}" destId="{5E8FED32-6440-4A80-887C-92E96B43FA43}" srcOrd="0" destOrd="0" presId="urn:microsoft.com/office/officeart/2005/8/layout/chevron1"/>
     <dgm:cxn modelId="{EA9DD16B-FD79-4D5C-ADFE-9816EC67C809}" type="presParOf" srcId="{44F33A45-1B21-4A97-AD63-8DB045734661}" destId="{18AB70F2-F9A8-4A92-9B17-67036A642D6A}" srcOrd="1" destOrd="0" presId="urn:microsoft.com/office/officeart/2005/8/layout/chevron1"/>
     <dgm:cxn modelId="{5D4B47B9-1CCE-4E56-975B-C3AB410A4D4F}" type="presParOf" srcId="{44F33A45-1B21-4A97-AD63-8DB045734661}" destId="{F4DC1C29-125F-43DC-B4CC-037FCD9EF089}" srcOrd="2" destOrd="0" presId="urn:microsoft.com/office/officeart/2005/8/layout/chevron1"/>
@@ -5950,7 +6040,7 @@
             <a:fld id="{B61BEF0D-F0BB-DE4B-95CE-6DB70DBA9567}" type="datetimeFigureOut">
               <a:rPr lang="en-US" smtClean="0"/>
               <a:pPr/>
-              <a:t>1/27/2026</a:t>
+              <a:t>1/29/2026</a:t>
             </a:fld>
             <a:endParaRPr lang="en-US" dirty="0"/>
           </a:p>
@@ -6173,7 +6263,7 @@
             <a:fld id="{B61BEF0D-F0BB-DE4B-95CE-6DB70DBA9567}" type="datetimeFigureOut">
               <a:rPr lang="en-US" smtClean="0"/>
               <a:pPr/>
-              <a:t>1/27/2026</a:t>
+              <a:t>1/29/2026</a:t>
             </a:fld>
             <a:endParaRPr lang="en-US" dirty="0"/>
           </a:p>
@@ -6355,7 +6445,7 @@
             <a:fld id="{B61BEF0D-F0BB-DE4B-95CE-6DB70DBA9567}" type="datetimeFigureOut">
               <a:rPr lang="en-US" smtClean="0"/>
               <a:pPr/>
-              <a:t>1/27/2026</a:t>
+              <a:t>1/29/2026</a:t>
             </a:fld>
             <a:endParaRPr lang="en-US" dirty="0"/>
           </a:p>
@@ -6527,7 +6617,7 @@
             <a:fld id="{B61BEF0D-F0BB-DE4B-95CE-6DB70DBA9567}" type="datetimeFigureOut">
               <a:rPr lang="en-US" smtClean="0"/>
               <a:pPr/>
-              <a:t>1/27/2026</a:t>
+              <a:t>1/29/2026</a:t>
             </a:fld>
             <a:endParaRPr lang="en-US" dirty="0"/>
           </a:p>
@@ -6780,7 +6870,7 @@
             <a:fld id="{B61BEF0D-F0BB-DE4B-95CE-6DB70DBA9567}" type="datetimeFigureOut">
               <a:rPr lang="en-US" smtClean="0"/>
               <a:pPr/>
-              <a:t>1/27/2026</a:t>
+              <a:t>1/29/2026</a:t>
             </a:fld>
             <a:endParaRPr lang="en-US" dirty="0"/>
           </a:p>
@@ -7105,7 +7195,7 @@
             <a:fld id="{B61BEF0D-F0BB-DE4B-95CE-6DB70DBA9567}" type="datetimeFigureOut">
               <a:rPr lang="en-US" smtClean="0"/>
               <a:pPr/>
-              <a:t>1/27/2026</a:t>
+              <a:t>1/29/2026</a:t>
             </a:fld>
             <a:endParaRPr lang="en-US" dirty="0"/>
           </a:p>
@@ -7531,7 +7621,7 @@
             <a:fld id="{B61BEF0D-F0BB-DE4B-95CE-6DB70DBA9567}" type="datetimeFigureOut">
               <a:rPr lang="en-US" smtClean="0"/>
               <a:pPr/>
-              <a:t>1/27/2026</a:t>
+              <a:t>1/29/2026</a:t>
             </a:fld>
             <a:endParaRPr lang="en-US" dirty="0"/>
           </a:p>
@@ -7651,7 +7741,7 @@
             <a:fld id="{B61BEF0D-F0BB-DE4B-95CE-6DB70DBA9567}" type="datetimeFigureOut">
               <a:rPr lang="en-US" smtClean="0"/>
               <a:pPr/>
-              <a:t>1/27/2026</a:t>
+              <a:t>1/29/2026</a:t>
             </a:fld>
             <a:endParaRPr lang="en-US" dirty="0"/>
           </a:p>
@@ -7748,7 +7838,7 @@
             <a:fld id="{B61BEF0D-F0BB-DE4B-95CE-6DB70DBA9567}" type="datetimeFigureOut">
               <a:rPr lang="en-US" smtClean="0"/>
               <a:pPr/>
-              <a:t>1/27/2026</a:t>
+              <a:t>1/29/2026</a:t>
             </a:fld>
             <a:endParaRPr lang="en-US" dirty="0"/>
           </a:p>
@@ -8040,7 +8130,7 @@
             <a:fld id="{B61BEF0D-F0BB-DE4B-95CE-6DB70DBA9567}" type="datetimeFigureOut">
               <a:rPr lang="en-US" smtClean="0"/>
               <a:pPr/>
-              <a:t>1/27/2026</a:t>
+              <a:t>1/29/2026</a:t>
             </a:fld>
             <a:endParaRPr lang="en-US" dirty="0"/>
           </a:p>
@@ -8314,7 +8404,7 @@
             <a:fld id="{B61BEF0D-F0BB-DE4B-95CE-6DB70DBA9567}" type="datetimeFigureOut">
               <a:rPr lang="en-US" smtClean="0"/>
               <a:pPr/>
-              <a:t>1/27/2026</a:t>
+              <a:t>1/29/2026</a:t>
             </a:fld>
             <a:endParaRPr lang="en-US" dirty="0"/>
           </a:p>
@@ -8570,7 +8660,7 @@
             <a:fld id="{B61BEF0D-F0BB-DE4B-95CE-6DB70DBA9567}" type="datetimeFigureOut">
               <a:rPr lang="en-US" smtClean="0"/>
               <a:pPr/>
-              <a:t>1/27/2026</a:t>
+              <a:t>1/29/2026</a:t>
             </a:fld>
             <a:endParaRPr lang="en-US" dirty="0"/>
           </a:p>
@@ -9887,6 +9977,776 @@
 </p:sld>
 </file>
 
+<file path=ppt/slides/slide6.xml><?xml version="1.0" encoding="utf-8"?>
+<p:sld xmlns:a="http://schemas.openxmlformats.org/drawingml/2006/main" xmlns:r="http://schemas.openxmlformats.org/officeDocument/2006/relationships" xmlns:p="http://schemas.openxmlformats.org/presentationml/2006/main">
+  <p:cSld>
+    <p:spTree>
+      <p:nvGrpSpPr>
+        <p:cNvPr id="1" name=""/>
+        <p:cNvGrpSpPr/>
+        <p:nvPr/>
+      </p:nvGrpSpPr>
+      <p:grpSpPr>
+        <a:xfrm>
+          <a:off x="0" y="0"/>
+          <a:ext cx="0" cy="0"/>
+          <a:chOff x="0" y="0"/>
+          <a:chExt cx="0" cy="0"/>
+        </a:xfrm>
+      </p:grpSpPr>
+      <p:graphicFrame>
+        <p:nvGraphicFramePr>
+          <p:cNvPr id="4" name="Table 3"/>
+          <p:cNvGraphicFramePr>
+            <a:graphicFrameLocks noGrp="1"/>
+          </p:cNvGraphicFramePr>
+          <p:nvPr>
+            <p:extLst>
+              <p:ext uri="{D42A27DB-BD31-4B8C-83A1-F6EECF244321}">
+                <p14:modId xmlns:p14="http://schemas.microsoft.com/office/powerpoint/2010/main" val="1807574924"/>
+              </p:ext>
+            </p:extLst>
+          </p:nvPr>
+        </p:nvGraphicFramePr>
+        <p:xfrm>
+          <a:off x="549496" y="436830"/>
+          <a:ext cx="4602052" cy="2053626"/>
+        </p:xfrm>
+        <a:graphic>
+          <a:graphicData uri="http://schemas.openxmlformats.org/drawingml/2006/table">
+            <a:tbl>
+              <a:tblPr>
+                <a:tableStyleId>{5C22544A-7EE6-4342-B048-85BDC9FD1C3A}</a:tableStyleId>
+              </a:tblPr>
+              <a:tblGrid>
+                <a:gridCol w="1150513"/>
+                <a:gridCol w="1150513"/>
+                <a:gridCol w="1150513"/>
+                <a:gridCol w="1150513"/>
+              </a:tblGrid>
+              <a:tr h="459123">
+                <a:tc>
+                  <a:txBody>
+                    <a:bodyPr/>
+                    <a:lstStyle/>
+                    <a:p>
+                      <a:pPr algn="l" fontAlgn="b"/>
+                      <a:r>
+                        <a:rPr lang="en-IN" sz="1800" u="none" strike="noStrike" dirty="0">
+                          <a:effectLst/>
+                        </a:rPr>
+                        <a:t>User Name</a:t>
+                      </a:r>
+                      <a:endParaRPr lang="en-IN" sz="1800" b="0" i="0" u="none" strike="noStrike" dirty="0">
+                        <a:solidFill>
+                          <a:srgbClr val="000000"/>
+                        </a:solidFill>
+                        <a:effectLst/>
+                        <a:latin typeface="Calibri" panose="020F0502020204030204" pitchFamily="34" charset="0"/>
+                      </a:endParaRPr>
+                    </a:p>
+                  </a:txBody>
+                  <a:tcPr marL="9525" marR="9525" marT="9525" marB="0" anchor="b"/>
+                </a:tc>
+                <a:tc>
+                  <a:txBody>
+                    <a:bodyPr/>
+                    <a:lstStyle/>
+                    <a:p>
+                      <a:pPr algn="l" fontAlgn="b"/>
+                      <a:r>
+                        <a:rPr lang="en-IN" sz="1800" u="none" strike="noStrike" dirty="0">
+                          <a:effectLst/>
+                        </a:rPr>
+                        <a:t>Password</a:t>
+                      </a:r>
+                      <a:endParaRPr lang="en-IN" sz="1800" b="0" i="0" u="none" strike="noStrike" dirty="0">
+                        <a:solidFill>
+                          <a:srgbClr val="000000"/>
+                        </a:solidFill>
+                        <a:effectLst/>
+                        <a:latin typeface="Calibri" panose="020F0502020204030204" pitchFamily="34" charset="0"/>
+                      </a:endParaRPr>
+                    </a:p>
+                  </a:txBody>
+                  <a:tcPr marL="9525" marR="9525" marT="9525" marB="0" anchor="b"/>
+                </a:tc>
+                <a:tc>
+                  <a:txBody>
+                    <a:bodyPr/>
+                    <a:lstStyle/>
+                    <a:p>
+                      <a:pPr algn="l" fontAlgn="b"/>
+                      <a:r>
+                        <a:rPr lang="en-IN" sz="1800" u="none" strike="noStrike" dirty="0">
+                          <a:effectLst/>
+                        </a:rPr>
+                        <a:t>Result</a:t>
+                      </a:r>
+                      <a:endParaRPr lang="en-IN" sz="1800" b="0" i="0" u="none" strike="noStrike" dirty="0">
+                        <a:solidFill>
+                          <a:srgbClr val="000000"/>
+                        </a:solidFill>
+                        <a:effectLst/>
+                        <a:latin typeface="Calibri" panose="020F0502020204030204" pitchFamily="34" charset="0"/>
+                      </a:endParaRPr>
+                    </a:p>
+                  </a:txBody>
+                  <a:tcPr marL="9525" marR="9525" marT="9525" marB="0" anchor="b"/>
+                </a:tc>
+                <a:tc>
+                  <a:txBody>
+                    <a:bodyPr/>
+                    <a:lstStyle/>
+                    <a:p>
+                      <a:pPr algn="l" fontAlgn="b"/>
+                      <a:r>
+                        <a:rPr lang="en-IN" sz="1800" u="none" strike="noStrike" dirty="0">
+                          <a:effectLst/>
+                        </a:rPr>
+                        <a:t>Message</a:t>
+                      </a:r>
+                      <a:endParaRPr lang="en-IN" sz="1800" b="0" i="0" u="none" strike="noStrike" dirty="0">
+                        <a:solidFill>
+                          <a:srgbClr val="000000"/>
+                        </a:solidFill>
+                        <a:effectLst/>
+                        <a:latin typeface="Calibri" panose="020F0502020204030204" pitchFamily="34" charset="0"/>
+                      </a:endParaRPr>
+                    </a:p>
+                  </a:txBody>
+                  <a:tcPr marL="9525" marR="9525" marT="9525" marB="0" anchor="b"/>
+                </a:tc>
+              </a:tr>
+              <a:tr h="253659">
+                <a:tc>
+                  <a:txBody>
+                    <a:bodyPr/>
+                    <a:lstStyle/>
+                    <a:p>
+                      <a:pPr algn="l" fontAlgn="b"/>
+                      <a:r>
+                        <a:rPr lang="en-IN" sz="1800" u="none" strike="noStrike" dirty="0" err="1">
+                          <a:effectLst/>
+                        </a:rPr>
+                        <a:t>priya</a:t>
+                      </a:r>
+                      <a:endParaRPr lang="en-IN" sz="1800" b="0" i="0" u="none" strike="noStrike" dirty="0">
+                        <a:solidFill>
+                          <a:srgbClr val="000000"/>
+                        </a:solidFill>
+                        <a:effectLst/>
+                        <a:latin typeface="Calibri" panose="020F0502020204030204" pitchFamily="34" charset="0"/>
+                      </a:endParaRPr>
+                    </a:p>
+                  </a:txBody>
+                  <a:tcPr marL="9525" marR="9525" marT="9525" marB="0" anchor="b"/>
+                </a:tc>
+                <a:tc>
+                  <a:txBody>
+                    <a:bodyPr/>
+                    <a:lstStyle/>
+                    <a:p>
+                      <a:pPr algn="l" fontAlgn="b"/>
+                      <a:r>
+                        <a:rPr lang="en-IN" sz="1800" u="none" strike="noStrike" dirty="0">
+                          <a:effectLst/>
+                        </a:rPr>
+                        <a:t>priya123</a:t>
+                      </a:r>
+                      <a:endParaRPr lang="en-IN" sz="1800" b="0" i="0" u="none" strike="noStrike" dirty="0">
+                        <a:solidFill>
+                          <a:srgbClr val="000000"/>
+                        </a:solidFill>
+                        <a:effectLst/>
+                        <a:latin typeface="Calibri" panose="020F0502020204030204" pitchFamily="34" charset="0"/>
+                      </a:endParaRPr>
+                    </a:p>
+                  </a:txBody>
+                  <a:tcPr marL="9525" marR="9525" marT="9525" marB="0" anchor="b"/>
+                </a:tc>
+                <a:tc>
+                  <a:txBody>
+                    <a:bodyPr/>
+                    <a:lstStyle/>
+                    <a:p>
+                      <a:pPr algn="l" fontAlgn="b"/>
+                      <a:r>
+                        <a:rPr lang="en-IN" sz="1800" u="none" strike="noStrike">
+                          <a:effectLst/>
+                        </a:rPr>
+                        <a:t>NotRun</a:t>
+                      </a:r>
+                      <a:endParaRPr lang="en-IN" sz="1800" b="0" i="0" u="none" strike="noStrike">
+                        <a:solidFill>
+                          <a:srgbClr val="000000"/>
+                        </a:solidFill>
+                        <a:effectLst/>
+                        <a:latin typeface="Calibri" panose="020F0502020204030204" pitchFamily="34" charset="0"/>
+                      </a:endParaRPr>
+                    </a:p>
+                  </a:txBody>
+                  <a:tcPr marL="9525" marR="9525" marT="9525" marB="0" anchor="b"/>
+                </a:tc>
+                <a:tc>
+                  <a:txBody>
+                    <a:bodyPr/>
+                    <a:lstStyle/>
+                    <a:p>
+                      <a:pPr algn="l" fontAlgn="b"/>
+                      <a:r>
+                        <a:rPr lang="en-IN" sz="1800" u="none" strike="noStrike">
+                          <a:effectLst/>
+                        </a:rPr>
+                        <a:t>NULL</a:t>
+                      </a:r>
+                      <a:endParaRPr lang="en-IN" sz="1800" b="0" i="0" u="none" strike="noStrike">
+                        <a:solidFill>
+                          <a:srgbClr val="000000"/>
+                        </a:solidFill>
+                        <a:effectLst/>
+                        <a:latin typeface="Calibri" panose="020F0502020204030204" pitchFamily="34" charset="0"/>
+                      </a:endParaRPr>
+                    </a:p>
+                  </a:txBody>
+                  <a:tcPr marL="9525" marR="9525" marT="9525" marB="0" anchor="b"/>
+                </a:tc>
+              </a:tr>
+              <a:tr h="253659">
+                <a:tc>
+                  <a:txBody>
+                    <a:bodyPr/>
+                    <a:lstStyle/>
+                    <a:p>
+                      <a:pPr algn="l" fontAlgn="b"/>
+                      <a:r>
+                        <a:rPr lang="en-IN" sz="1800" u="none" strike="noStrike">
+                          <a:effectLst/>
+                        </a:rPr>
+                        <a:t>ankit</a:t>
+                      </a:r>
+                      <a:endParaRPr lang="en-IN" sz="1800" b="0" i="0" u="none" strike="noStrike">
+                        <a:solidFill>
+                          <a:srgbClr val="000000"/>
+                        </a:solidFill>
+                        <a:effectLst/>
+                        <a:latin typeface="Calibri" panose="020F0502020204030204" pitchFamily="34" charset="0"/>
+                      </a:endParaRPr>
+                    </a:p>
+                  </a:txBody>
+                  <a:tcPr marL="9525" marR="9525" marT="9525" marB="0" anchor="b"/>
+                </a:tc>
+                <a:tc>
+                  <a:txBody>
+                    <a:bodyPr/>
+                    <a:lstStyle/>
+                    <a:p>
+                      <a:pPr algn="l" fontAlgn="b"/>
+                      <a:r>
+                        <a:rPr lang="en-IN" sz="1800" u="none" strike="noStrike">
+                          <a:effectLst/>
+                        </a:rPr>
+                        <a:t>ankit123</a:t>
+                      </a:r>
+                      <a:endParaRPr lang="en-IN" sz="1800" b="0" i="0" u="none" strike="noStrike">
+                        <a:solidFill>
+                          <a:srgbClr val="000000"/>
+                        </a:solidFill>
+                        <a:effectLst/>
+                        <a:latin typeface="Calibri" panose="020F0502020204030204" pitchFamily="34" charset="0"/>
+                      </a:endParaRPr>
+                    </a:p>
+                  </a:txBody>
+                  <a:tcPr marL="9525" marR="9525" marT="9525" marB="0" anchor="b"/>
+                </a:tc>
+                <a:tc>
+                  <a:txBody>
+                    <a:bodyPr/>
+                    <a:lstStyle/>
+                    <a:p>
+                      <a:pPr algn="l" fontAlgn="b"/>
+                      <a:r>
+                        <a:rPr lang="en-IN" sz="1800" u="none" strike="noStrike">
+                          <a:effectLst/>
+                        </a:rPr>
+                        <a:t>NotRun</a:t>
+                      </a:r>
+                      <a:endParaRPr lang="en-IN" sz="1800" b="0" i="0" u="none" strike="noStrike">
+                        <a:solidFill>
+                          <a:srgbClr val="000000"/>
+                        </a:solidFill>
+                        <a:effectLst/>
+                        <a:latin typeface="Calibri" panose="020F0502020204030204" pitchFamily="34" charset="0"/>
+                      </a:endParaRPr>
+                    </a:p>
+                  </a:txBody>
+                  <a:tcPr marL="9525" marR="9525" marT="9525" marB="0" anchor="b"/>
+                </a:tc>
+                <a:tc>
+                  <a:txBody>
+                    <a:bodyPr/>
+                    <a:lstStyle/>
+                    <a:p>
+                      <a:pPr algn="l" fontAlgn="b"/>
+                      <a:r>
+                        <a:rPr lang="en-IN" sz="1800" u="none" strike="noStrike">
+                          <a:effectLst/>
+                        </a:rPr>
+                        <a:t>NULL</a:t>
+                      </a:r>
+                      <a:endParaRPr lang="en-IN" sz="1800" b="0" i="0" u="none" strike="noStrike">
+                        <a:solidFill>
+                          <a:srgbClr val="000000"/>
+                        </a:solidFill>
+                        <a:effectLst/>
+                        <a:latin typeface="Calibri" panose="020F0502020204030204" pitchFamily="34" charset="0"/>
+                      </a:endParaRPr>
+                    </a:p>
+                  </a:txBody>
+                  <a:tcPr marL="9525" marR="9525" marT="9525" marB="0" anchor="b"/>
+                </a:tc>
+              </a:tr>
+              <a:tr h="253659">
+                <a:tc>
+                  <a:txBody>
+                    <a:bodyPr/>
+                    <a:lstStyle/>
+                    <a:p>
+                      <a:pPr algn="l" fontAlgn="b"/>
+                      <a:r>
+                        <a:rPr lang="en-IN" sz="1800" u="none" strike="noStrike">
+                          <a:effectLst/>
+                        </a:rPr>
+                        <a:t>admin</a:t>
+                      </a:r>
+                      <a:endParaRPr lang="en-IN" sz="1800" b="0" i="0" u="none" strike="noStrike">
+                        <a:solidFill>
+                          <a:srgbClr val="000000"/>
+                        </a:solidFill>
+                        <a:effectLst/>
+                        <a:latin typeface="Calibri" panose="020F0502020204030204" pitchFamily="34" charset="0"/>
+                      </a:endParaRPr>
+                    </a:p>
+                  </a:txBody>
+                  <a:tcPr marL="9525" marR="9525" marT="9525" marB="0" anchor="b"/>
+                </a:tc>
+                <a:tc>
+                  <a:txBody>
+                    <a:bodyPr/>
+                    <a:lstStyle/>
+                    <a:p>
+                      <a:pPr algn="l" fontAlgn="b"/>
+                      <a:r>
+                        <a:rPr lang="en-IN" sz="1800" u="none" strike="noStrike">
+                          <a:effectLst/>
+                        </a:rPr>
+                        <a:t>admin123</a:t>
+                      </a:r>
+                      <a:endParaRPr lang="en-IN" sz="1800" b="0" i="0" u="none" strike="noStrike">
+                        <a:solidFill>
+                          <a:srgbClr val="000000"/>
+                        </a:solidFill>
+                        <a:effectLst/>
+                        <a:latin typeface="Calibri" panose="020F0502020204030204" pitchFamily="34" charset="0"/>
+                      </a:endParaRPr>
+                    </a:p>
+                  </a:txBody>
+                  <a:tcPr marL="9525" marR="9525" marT="9525" marB="0" anchor="b"/>
+                </a:tc>
+                <a:tc>
+                  <a:txBody>
+                    <a:bodyPr/>
+                    <a:lstStyle/>
+                    <a:p>
+                      <a:pPr algn="l" fontAlgn="b"/>
+                      <a:r>
+                        <a:rPr lang="en-IN" sz="1800" u="none" strike="noStrike">
+                          <a:effectLst/>
+                        </a:rPr>
+                        <a:t>NotRun</a:t>
+                      </a:r>
+                      <a:endParaRPr lang="en-IN" sz="1800" b="0" i="0" u="none" strike="noStrike">
+                        <a:solidFill>
+                          <a:srgbClr val="000000"/>
+                        </a:solidFill>
+                        <a:effectLst/>
+                        <a:latin typeface="Calibri" panose="020F0502020204030204" pitchFamily="34" charset="0"/>
+                      </a:endParaRPr>
+                    </a:p>
+                  </a:txBody>
+                  <a:tcPr marL="9525" marR="9525" marT="9525" marB="0" anchor="b"/>
+                </a:tc>
+                <a:tc>
+                  <a:txBody>
+                    <a:bodyPr/>
+                    <a:lstStyle/>
+                    <a:p>
+                      <a:pPr algn="l" fontAlgn="b"/>
+                      <a:r>
+                        <a:rPr lang="en-IN" sz="1800" u="none" strike="noStrike">
+                          <a:effectLst/>
+                        </a:rPr>
+                        <a:t>NULL</a:t>
+                      </a:r>
+                      <a:endParaRPr lang="en-IN" sz="1800" b="0" i="0" u="none" strike="noStrike">
+                        <a:solidFill>
+                          <a:srgbClr val="000000"/>
+                        </a:solidFill>
+                        <a:effectLst/>
+                        <a:latin typeface="Calibri" panose="020F0502020204030204" pitchFamily="34" charset="0"/>
+                      </a:endParaRPr>
+                    </a:p>
+                  </a:txBody>
+                  <a:tcPr marL="9525" marR="9525" marT="9525" marB="0" anchor="b"/>
+                </a:tc>
+              </a:tr>
+              <a:tr h="459123">
+                <a:tc>
+                  <a:txBody>
+                    <a:bodyPr/>
+                    <a:lstStyle/>
+                    <a:p>
+                      <a:pPr algn="l" fontAlgn="b"/>
+                      <a:r>
+                        <a:rPr lang="en-IN" sz="1800" u="none" strike="noStrike">
+                          <a:effectLst/>
+                        </a:rPr>
+                        <a:t>abhinav</a:t>
+                      </a:r>
+                      <a:endParaRPr lang="en-IN" sz="1800" b="0" i="0" u="none" strike="noStrike">
+                        <a:solidFill>
+                          <a:srgbClr val="000000"/>
+                        </a:solidFill>
+                        <a:effectLst/>
+                        <a:latin typeface="Calibri" panose="020F0502020204030204" pitchFamily="34" charset="0"/>
+                      </a:endParaRPr>
+                    </a:p>
+                  </a:txBody>
+                  <a:tcPr marL="9525" marR="9525" marT="9525" marB="0" anchor="b"/>
+                </a:tc>
+                <a:tc>
+                  <a:txBody>
+                    <a:bodyPr/>
+                    <a:lstStyle/>
+                    <a:p>
+                      <a:pPr algn="l" fontAlgn="b"/>
+                      <a:r>
+                        <a:rPr lang="en-IN" sz="1800" u="none" strike="noStrike">
+                          <a:effectLst/>
+                        </a:rPr>
+                        <a:t>abhinav123</a:t>
+                      </a:r>
+                      <a:endParaRPr lang="en-IN" sz="1800" b="0" i="0" u="none" strike="noStrike">
+                        <a:solidFill>
+                          <a:srgbClr val="000000"/>
+                        </a:solidFill>
+                        <a:effectLst/>
+                        <a:latin typeface="Calibri" panose="020F0502020204030204" pitchFamily="34" charset="0"/>
+                      </a:endParaRPr>
+                    </a:p>
+                  </a:txBody>
+                  <a:tcPr marL="9525" marR="9525" marT="9525" marB="0" anchor="b"/>
+                </a:tc>
+                <a:tc>
+                  <a:txBody>
+                    <a:bodyPr/>
+                    <a:lstStyle/>
+                    <a:p>
+                      <a:pPr algn="l" fontAlgn="b"/>
+                      <a:r>
+                        <a:rPr lang="en-IN" sz="1800" u="none" strike="noStrike">
+                          <a:effectLst/>
+                        </a:rPr>
+                        <a:t>NotRun</a:t>
+                      </a:r>
+                      <a:endParaRPr lang="en-IN" sz="1800" b="0" i="0" u="none" strike="noStrike">
+                        <a:solidFill>
+                          <a:srgbClr val="000000"/>
+                        </a:solidFill>
+                        <a:effectLst/>
+                        <a:latin typeface="Calibri" panose="020F0502020204030204" pitchFamily="34" charset="0"/>
+                      </a:endParaRPr>
+                    </a:p>
+                  </a:txBody>
+                  <a:tcPr marL="9525" marR="9525" marT="9525" marB="0" anchor="b"/>
+                </a:tc>
+                <a:tc>
+                  <a:txBody>
+                    <a:bodyPr/>
+                    <a:lstStyle/>
+                    <a:p>
+                      <a:pPr algn="l" fontAlgn="b"/>
+                      <a:r>
+                        <a:rPr lang="en-IN" sz="1800" u="none" strike="noStrike">
+                          <a:effectLst/>
+                        </a:rPr>
+                        <a:t>NULL</a:t>
+                      </a:r>
+                      <a:endParaRPr lang="en-IN" sz="1800" b="0" i="0" u="none" strike="noStrike">
+                        <a:solidFill>
+                          <a:srgbClr val="000000"/>
+                        </a:solidFill>
+                        <a:effectLst/>
+                        <a:latin typeface="Calibri" panose="020F0502020204030204" pitchFamily="34" charset="0"/>
+                      </a:endParaRPr>
+                    </a:p>
+                  </a:txBody>
+                  <a:tcPr marL="9525" marR="9525" marT="9525" marB="0" anchor="b"/>
+                </a:tc>
+              </a:tr>
+              <a:tr h="253659">
+                <a:tc>
+                  <a:txBody>
+                    <a:bodyPr/>
+                    <a:lstStyle/>
+                    <a:p>
+                      <a:pPr algn="l" fontAlgn="b"/>
+                      <a:r>
+                        <a:rPr lang="en-IN" sz="1800" u="none" strike="noStrike">
+                          <a:effectLst/>
+                        </a:rPr>
+                        <a:t>admin</a:t>
+                      </a:r>
+                      <a:endParaRPr lang="en-IN" sz="1800" b="0" i="0" u="none" strike="noStrike">
+                        <a:solidFill>
+                          <a:srgbClr val="000000"/>
+                        </a:solidFill>
+                        <a:effectLst/>
+                        <a:latin typeface="Calibri" panose="020F0502020204030204" pitchFamily="34" charset="0"/>
+                      </a:endParaRPr>
+                    </a:p>
+                  </a:txBody>
+                  <a:tcPr marL="9525" marR="9525" marT="9525" marB="0" anchor="b"/>
+                </a:tc>
+                <a:tc>
+                  <a:txBody>
+                    <a:bodyPr/>
+                    <a:lstStyle/>
+                    <a:p>
+                      <a:pPr algn="l" fontAlgn="b"/>
+                      <a:r>
+                        <a:rPr lang="en-IN" sz="1800" u="none" strike="noStrike">
+                          <a:effectLst/>
+                        </a:rPr>
+                        <a:t>admin123</a:t>
+                      </a:r>
+                      <a:endParaRPr lang="en-IN" sz="1800" b="0" i="0" u="none" strike="noStrike">
+                        <a:solidFill>
+                          <a:srgbClr val="000000"/>
+                        </a:solidFill>
+                        <a:effectLst/>
+                        <a:latin typeface="Calibri" panose="020F0502020204030204" pitchFamily="34" charset="0"/>
+                      </a:endParaRPr>
+                    </a:p>
+                  </a:txBody>
+                  <a:tcPr marL="9525" marR="9525" marT="9525" marB="0" anchor="b"/>
+                </a:tc>
+                <a:tc>
+                  <a:txBody>
+                    <a:bodyPr/>
+                    <a:lstStyle/>
+                    <a:p>
+                      <a:pPr algn="l" fontAlgn="b"/>
+                      <a:r>
+                        <a:rPr lang="en-IN" sz="1800" u="none" strike="noStrike">
+                          <a:effectLst/>
+                        </a:rPr>
+                        <a:t>NotRun</a:t>
+                      </a:r>
+                      <a:endParaRPr lang="en-IN" sz="1800" b="0" i="0" u="none" strike="noStrike">
+                        <a:solidFill>
+                          <a:srgbClr val="000000"/>
+                        </a:solidFill>
+                        <a:effectLst/>
+                        <a:latin typeface="Calibri" panose="020F0502020204030204" pitchFamily="34" charset="0"/>
+                      </a:endParaRPr>
+                    </a:p>
+                  </a:txBody>
+                  <a:tcPr marL="9525" marR="9525" marT="9525" marB="0" anchor="b"/>
+                </a:tc>
+                <a:tc>
+                  <a:txBody>
+                    <a:bodyPr/>
+                    <a:lstStyle/>
+                    <a:p>
+                      <a:pPr algn="l" fontAlgn="b"/>
+                      <a:r>
+                        <a:rPr lang="en-IN" sz="1800" u="none" strike="noStrike" dirty="0">
+                          <a:effectLst/>
+                        </a:rPr>
+                        <a:t>NULL</a:t>
+                      </a:r>
+                      <a:endParaRPr lang="en-IN" sz="1800" b="0" i="0" u="none" strike="noStrike" dirty="0">
+                        <a:solidFill>
+                          <a:srgbClr val="000000"/>
+                        </a:solidFill>
+                        <a:effectLst/>
+                        <a:latin typeface="Calibri" panose="020F0502020204030204" pitchFamily="34" charset="0"/>
+                      </a:endParaRPr>
+                    </a:p>
+                  </a:txBody>
+                  <a:tcPr marL="9525" marR="9525" marT="9525" marB="0" anchor="b"/>
+                </a:tc>
+              </a:tr>
+            </a:tbl>
+          </a:graphicData>
+        </a:graphic>
+      </p:graphicFrame>
+      <p:graphicFrame>
+        <p:nvGraphicFramePr>
+          <p:cNvPr id="5" name="Table 4"/>
+          <p:cNvGraphicFramePr>
+            <a:graphicFrameLocks noGrp="1"/>
+          </p:cNvGraphicFramePr>
+          <p:nvPr>
+            <p:extLst>
+              <p:ext uri="{D42A27DB-BD31-4B8C-83A1-F6EECF244321}">
+                <p14:modId xmlns:p14="http://schemas.microsoft.com/office/powerpoint/2010/main" val="3624016817"/>
+              </p:ext>
+            </p:extLst>
+          </p:nvPr>
+        </p:nvGraphicFramePr>
+        <p:xfrm>
+          <a:off x="666840" y="3308320"/>
+          <a:ext cx="4064000" cy="1854200"/>
+        </p:xfrm>
+        <a:graphic>
+          <a:graphicData uri="http://schemas.openxmlformats.org/drawingml/2006/table">
+            <a:tbl>
+              <a:tblPr firstRow="1" bandRow="1">
+                <a:tableStyleId>{5940675A-B579-460E-94D1-54222C63F5DA}</a:tableStyleId>
+              </a:tblPr>
+              <a:tblGrid>
+                <a:gridCol w="2032000"/>
+                <a:gridCol w="2032000"/>
+              </a:tblGrid>
+              <a:tr h="370840">
+                <a:tc>
+                  <a:txBody>
+                    <a:bodyPr/>
+                    <a:lstStyle/>
+                    <a:p>
+                      <a:endParaRPr lang="en-IN" dirty="0"/>
+                    </a:p>
+                  </a:txBody>
+                  <a:tcPr/>
+                </a:tc>
+                <a:tc>
+                  <a:txBody>
+                    <a:bodyPr/>
+                    <a:lstStyle/>
+                    <a:p>
+                      <a:endParaRPr lang="en-IN"/>
+                    </a:p>
+                  </a:txBody>
+                  <a:tcPr/>
+                </a:tc>
+              </a:tr>
+              <a:tr h="370840">
+                <a:tc>
+                  <a:txBody>
+                    <a:bodyPr/>
+                    <a:lstStyle/>
+                    <a:p>
+                      <a:endParaRPr lang="en-IN"/>
+                    </a:p>
+                  </a:txBody>
+                  <a:tcPr/>
+                </a:tc>
+                <a:tc>
+                  <a:txBody>
+                    <a:bodyPr/>
+                    <a:lstStyle/>
+                    <a:p>
+                      <a:endParaRPr lang="en-IN"/>
+                    </a:p>
+                  </a:txBody>
+                  <a:tcPr/>
+                </a:tc>
+              </a:tr>
+              <a:tr h="370840">
+                <a:tc>
+                  <a:txBody>
+                    <a:bodyPr/>
+                    <a:lstStyle/>
+                    <a:p>
+                      <a:endParaRPr lang="en-IN"/>
+                    </a:p>
+                  </a:txBody>
+                  <a:tcPr/>
+                </a:tc>
+                <a:tc>
+                  <a:txBody>
+                    <a:bodyPr/>
+                    <a:lstStyle/>
+                    <a:p>
+                      <a:endParaRPr lang="en-IN"/>
+                    </a:p>
+                  </a:txBody>
+                  <a:tcPr/>
+                </a:tc>
+              </a:tr>
+              <a:tr h="370840">
+                <a:tc>
+                  <a:txBody>
+                    <a:bodyPr/>
+                    <a:lstStyle/>
+                    <a:p>
+                      <a:endParaRPr lang="en-IN"/>
+                    </a:p>
+                  </a:txBody>
+                  <a:tcPr/>
+                </a:tc>
+                <a:tc>
+                  <a:txBody>
+                    <a:bodyPr/>
+                    <a:lstStyle/>
+                    <a:p>
+                      <a:endParaRPr lang="en-IN"/>
+                    </a:p>
+                  </a:txBody>
+                  <a:tcPr/>
+                </a:tc>
+              </a:tr>
+              <a:tr h="370840">
+                <a:tc>
+                  <a:txBody>
+                    <a:bodyPr/>
+                    <a:lstStyle/>
+                    <a:p>
+                      <a:endParaRPr lang="en-IN"/>
+                    </a:p>
+                  </a:txBody>
+                  <a:tcPr/>
+                </a:tc>
+                <a:tc>
+                  <a:txBody>
+                    <a:bodyPr/>
+                    <a:lstStyle/>
+                    <a:p>
+                      <a:endParaRPr lang="en-IN" dirty="0"/>
+                    </a:p>
+                  </a:txBody>
+                  <a:tcPr/>
+                </a:tc>
+              </a:tr>
+            </a:tbl>
+          </a:graphicData>
+        </a:graphic>
+      </p:graphicFrame>
+    </p:spTree>
+    <p:extLst>
+      <p:ext uri="{BB962C8B-B14F-4D97-AF65-F5344CB8AC3E}">
+        <p14:creationId xmlns:p14="http://schemas.microsoft.com/office/powerpoint/2010/main" val="230050074"/>
+      </p:ext>
+    </p:extLst>
+  </p:cSld>
+  <p:clrMapOvr>
+    <a:masterClrMapping/>
+  </p:clrMapOvr>
+</p:sld>
+</file>
+
 <file path=ppt/theme/theme1.xml><?xml version="1.0" encoding="utf-8"?>
 <a:theme xmlns:a="http://schemas.openxmlformats.org/drawingml/2006/main" name="Basis">
   <a:themeElements>

</xml_diff>